<commit_message>
feat: Update site content and localization
- Translated "About" page to Portuguese and updated author information.
- Enhanced blog enhancements script for better user experience with localized text.
- Updated privacy policy to reflect data collection practices and compliance with LGPD.
- Added localization support for Portuguese in the site structure.
- Updated custom styles in SCSS for improved design consistency.
- Added new dependencies in requirements.txt for additional functionality.
- Removed unnecessary robots.txt file.
- Updated AI post generation script to reflect new blog title and content guidelines.
- Added author data configuration for better content management.
- Configured stylelint for SCSS to enforce coding standards.
</commit_message>
<xml_diff>
--- a/_course_production/M00_Introducao/apresentacao_final.pptx
+++ b/_course_production/M00_Introducao/apresentacao_final.pptx
@@ -3146,7 +3146,7 @@
               </a:defRPr>
             </a:pPr>
             <a:r>
-              <a:t>¿Blog Visual, Rápido y Gratis?</a:t>
+              <a:t>Blog profissional sem custo de hospedagem</a:t>
             </a:r>
           </a:p>
         </p:txBody>
@@ -3313,7 +3313,7 @@
               </a:defRPr>
             </a:pPr>
             <a:r>
-              <a:t>Antes de empezar</a:t>
+              <a:t>Antes de começar</a:t>
             </a:r>
           </a:p>
         </p:txBody>
@@ -3349,7 +3349,7 @@
               </a:defRPr>
             </a:pPr>
             <a:r>
-              <a:t>✅ Windows 10 o superior</a:t>
+              <a:t>✅ Windows 10 ou superior</a:t>
             </a:r>
           </a:p>
         </p:txBody>
@@ -3385,7 +3385,7 @@
               </a:defRPr>
             </a:pPr>
             <a:r>
-              <a:t>✅ Conexión a Internet</a:t>
+              <a:t>✅ Conexão com a internet</a:t>
             </a:r>
           </a:p>
         </p:txBody>
@@ -3421,7 +3421,7 @@
               </a:defRPr>
             </a:pPr>
             <a:r>
-              <a:t>✅ ~30 minutos de tu tiempo</a:t>
+              <a:t>✅ Cerca de 30 minutos disponíveis</a:t>
             </a:r>
           </a:p>
         </p:txBody>
@@ -3457,7 +3457,7 @@
               </a:defRPr>
             </a:pPr>
             <a:r>
-              <a:t>✅ Voluntad de aprender</a:t>
+              <a:t>✅ Vontade de aprender</a:t>
             </a:r>
           </a:p>
         </p:txBody>
@@ -3512,7 +3512,7 @@
               </a:defRPr>
             </a:pPr>
             <a:r>
-              <a:t>⚠️ AVISO IMPORTANTE</a:t>
+              <a:t>⚠️ IMPORTANTE</a:t>
             </a:r>
           </a:p>
           <a:p>
@@ -3535,7 +3535,7 @@
               </a:defRPr>
             </a:pPr>
             <a:r>
-              <a:t>Esto es fácil, pero requiere atención en cada paso.</a:t>
+              <a:t>O processo é acessível, mas exige atenção em cada etapa.</a:t>
             </a:r>
           </a:p>
           <a:p>
@@ -3548,7 +3548,7 @@
               </a:defRPr>
             </a:pPr>
             <a:r>
-              <a:t>Afortunadamente, si te atascas, estoy aquí para ayudarte.</a:t>
+              <a:t>Se surgir alguma dúvida, estarei aqui para ajudar.</a:t>
             </a:r>
           </a:p>
         </p:txBody>
@@ -3618,7 +3618,7 @@
               </a:defRPr>
             </a:pPr>
             <a:r>
-              <a:t>¿ESTÁS LISTO?</a:t>
+              <a:t>VAMOS COMEÇAR?</a:t>
             </a:r>
           </a:p>
         </p:txBody>
@@ -3654,7 +3654,7 @@
               </a:defRPr>
             </a:pPr>
             <a:r>
-              <a:t>En el siguiente video:</a:t>
+              <a:t>No próximo vídeo:</a:t>
             </a:r>
           </a:p>
           <a:p>
@@ -3667,7 +3667,7 @@
               </a:defRPr>
             </a:pPr>
             <a:r>
-              <a:t>Instalamos Ruby + Git + Jekyll</a:t>
+              <a:t>Vamos instalar Ruby + Git + Jekyll</a:t>
             </a:r>
           </a:p>
         </p:txBody>
@@ -3720,7 +3720,7 @@
               </a:defRPr>
             </a:pPr>
             <a:r>
-              <a:t>👉 VER MÓDULO 1</a:t>
+              <a:t>👉 IR PARA O MÓDULO 1</a:t>
             </a:r>
           </a:p>
         </p:txBody>
@@ -3756,7 +3756,7 @@
               </a:defRPr>
             </a:pPr>
             <a:r>
-              <a:t>Deja un comentario abajo. Dime qué te emociona más.</a:t>
+              <a:t>Deixe um comentário: o que mais despertou seu interesse?</a:t>
             </a:r>
           </a:p>
         </p:txBody>
@@ -3826,7 +3826,7 @@
               </a:defRPr>
             </a:pPr>
             <a:r>
-              <a:t>¡Nos vemos en el siguiente módulo!</a:t>
+              <a:t>Até o próximo módulo!</a:t>
             </a:r>
           </a:p>
         </p:txBody>
@@ -3875,7 +3875,7 @@
               </a:defRPr>
             </a:pPr>
             <a:r>
-              <a:t>💻 Windows Setup</a:t>
+              <a:t>💻 Configuração no Windows</a:t>
             </a:r>
           </a:p>
           <a:p>
@@ -3888,7 +3888,7 @@
               </a:defRPr>
             </a:pPr>
             <a:r>
-              <a:t>🚀 Blog profesional sin costos</a:t>
+              <a:t>🚀 Blog profissional sem custo de hospedagem</a:t>
             </a:r>
           </a:p>
         </p:txBody>
@@ -3960,7 +3960,7 @@
               </a:defRPr>
             </a:pPr>
             <a:r>
-              <a:t>Data Engineer | AI Specialist</a:t>
+              <a:t>Engenheiro de Dados | Especialista em IA</a:t>
             </a:r>
           </a:p>
         </p:txBody>
@@ -3996,7 +3996,7 @@
               </a:defRPr>
             </a:pPr>
             <a:r>
-              <a:t>Más de 20 años de experiencia en tecnología e IA</a:t>
+              <a:t>Mais de 20 anos de experiência em tecnologia e IA</a:t>
             </a:r>
           </a:p>
         </p:txBody>
@@ -4032,7 +4032,20 @@
               </a:defRPr>
             </a:pPr>
             <a:r>
-              <a:t>🔗 blog.dataengineer.net.br  |  📧 [tu-email]  |  💼 LinkedIn</a:t>
+              <a:t>🔗 marcos-data-engineer.github.io/blog</a:t>
+            </a:r>
+          </a:p>
+          <a:p>
+            <a:pPr algn="ctr">
+              <a:defRPr sz="1200">
+                <a:solidFill>
+                  <a:srgbClr val="FFFFFF"/>
+                </a:solidFill>
+                <a:latin typeface="Inter"/>
+              </a:defRPr>
+            </a:pPr>
+            <a:r>
+              <a:t>📧 contact.marcos.dataengineer@gmail.com  |  💼 linkedin.com/in/marcos-data-engineer</a:t>
             </a:r>
           </a:p>
         </p:txBody>
@@ -4094,7 +4107,7 @@
               </a:defRPr>
             </a:pPr>
             <a:r>
-              <a:t>¿Cansado de pagar</a:t>
+              <a:t>Cansado de pagar</a:t>
             </a:r>
           </a:p>
           <a:p>
@@ -4107,7 +4120,7 @@
               </a:defRPr>
             </a:pPr>
             <a:r>
-              <a:t>por hosting?</a:t>
+              <a:t>por hospedagem?</a:t>
             </a:r>
           </a:p>
         </p:txBody>
@@ -4143,7 +4156,7 @@
               </a:defRPr>
             </a:pPr>
             <a:r>
-              <a:t>¿No quieres complicarte</a:t>
+              <a:t>Quer evitar as complicações</a:t>
             </a:r>
           </a:p>
           <a:p>
@@ -4156,7 +4169,7 @@
               </a:defRPr>
             </a:pPr>
             <a:r>
-              <a:t>con WordPress?</a:t>
+              <a:t>do WordPress?</a:t>
             </a:r>
           </a:p>
         </p:txBody>
@@ -4192,7 +4205,7 @@
               </a:defRPr>
             </a:pPr>
             <a:r>
-              <a:t>✓ TENEMOS BUENAS NOTICIAS</a:t>
+              <a:t>✓ TEMOS UMA BOA NOTÍCIA</a:t>
             </a:r>
           </a:p>
         </p:txBody>
@@ -4228,7 +4241,7 @@
               </a:defRPr>
             </a:pPr>
             <a:r>
-              <a:t>Puedes crear un blog</a:t>
+              <a:t>Você pode criar um blog</a:t>
             </a:r>
           </a:p>
           <a:p>
@@ -4241,12 +4254,12 @@
               </a:defRPr>
             </a:pPr>
             <a:r>
-              <a:t>PROFESIONAL</a:t>
+              <a:t>PROFISSIONAL</a:t>
             </a:r>
           </a:p>
           <a:p>
             <a:pPr>
-              <a:defRPr b="1" sz="2400">
+              <a:defRPr sz="1800">
                 <a:solidFill>
                   <a:srgbClr val="374151"/>
                 </a:solidFill>
@@ -4254,7 +4267,7 @@
               </a:defRPr>
             </a:pPr>
             <a:r>
-              <a:t>GRATIS</a:t>
+              <a:t>com hospedagem sem custo</a:t>
             </a:r>
           </a:p>
         </p:txBody>
@@ -4308,11 +4321,11 @@
               </a:defRPr>
             </a:pPr>
             <a:r>
-              <a:t>[Tu blog screenshot aquí]</a:t>
+              <a:t>[Insira uma captura de tela do seu blog]</a:t>
             </a:r>
             <a:br/>
             <a:r>
-              <a:t>(blog.dataengineer.net.br)</a:t>
+              <a:t>(marcos-data-engineer.github.io/blog)</a:t>
             </a:r>
           </a:p>
         </p:txBody>
@@ -4453,7 +4466,7 @@
               </a:defRPr>
             </a:pPr>
             <a:r>
-              <a:t>Instalar todo lo necesario</a:t>
+              <a:t>Instalar tudo o que é necessário</a:t>
             </a:r>
           </a:p>
         </p:txBody>
@@ -4502,7 +4515,7 @@
               </a:defRPr>
             </a:pPr>
             <a:r>
-              <a:t>Paso a paso. Sin complicaciones.</a:t>
+              <a:t>Passo a passo, sem complicação.</a:t>
             </a:r>
           </a:p>
         </p:txBody>
@@ -4643,7 +4656,7 @@
               </a:defRPr>
             </a:pPr>
             <a:r>
-              <a:t>Crear tu primer blog</a:t>
+              <a:t>Crie seu primeiro blog</a:t>
             </a:r>
           </a:p>
         </p:txBody>
@@ -4679,7 +4692,7 @@
               </a:defRPr>
             </a:pPr>
             <a:r>
-              <a:t>Con tus propios artículos</a:t>
+              <a:t>Com seus próprios artigos</a:t>
             </a:r>
           </a:p>
           <a:p>
@@ -4692,7 +4705,7 @@
               </a:defRPr>
             </a:pPr>
             <a:r>
-              <a:t>Estructura profesional</a:t>
+              <a:t>Estrutura profissional</a:t>
             </a:r>
           </a:p>
           <a:p>
@@ -4705,7 +4718,7 @@
               </a:defRPr>
             </a:pPr>
             <a:r>
-              <a:t>Diseño limpio</a:t>
+              <a:t>Design limpo</a:t>
             </a:r>
           </a:p>
         </p:txBody>
@@ -4846,7 +4859,7 @@
               </a:defRPr>
             </a:pPr>
             <a:r>
-              <a:t>Publicar en GitHub Pages</a:t>
+              <a:t>Publique no GitHub Pages</a:t>
             </a:r>
           </a:p>
         </p:txBody>
@@ -4882,7 +4895,7 @@
               </a:defRPr>
             </a:pPr>
             <a:r>
-              <a:t>Tu dominio gratis</a:t>
+              <a:t>Seu site no ar sem custo de hospedagem</a:t>
             </a:r>
           </a:p>
           <a:p>
@@ -4895,7 +4908,7 @@
               </a:defRPr>
             </a:pPr>
             <a:r>
-              <a:t>Online en minutos</a:t>
+              <a:t>Publicação pelo GitHub Pages</a:t>
             </a:r>
           </a:p>
           <a:p>
@@ -4908,7 +4921,7 @@
               </a:defRPr>
             </a:pPr>
             <a:r>
-              <a:t>Control total</a:t>
+              <a:t>Conteúdo versionado com Git</a:t>
             </a:r>
           </a:p>
         </p:txBody>
@@ -5049,7 +5062,7 @@
               </a:defRPr>
             </a:pPr>
             <a:r>
-              <a:t>El siguiente paso</a:t>
+              <a:t>Próximos passos</a:t>
             </a:r>
           </a:p>
         </p:txBody>
@@ -5085,7 +5098,7 @@
               </a:defRPr>
             </a:pPr>
             <a:r>
-              <a:t>Monetizar tu blog</a:t>
+              <a:t>Monetize seu blog</a:t>
             </a:r>
           </a:p>
           <a:p>
@@ -5098,7 +5111,7 @@
               </a:defRPr>
             </a:pPr>
             <a:r>
-              <a:t>Hacer crecer tu audiencia</a:t>
+              <a:t>Amplie seu público</a:t>
             </a:r>
           </a:p>
           <a:p>
@@ -5111,7 +5124,7 @@
               </a:defRPr>
             </a:pPr>
             <a:r>
-              <a:t>Nuevas oportunidades</a:t>
+              <a:t>Descubra novas oportunidades</a:t>
             </a:r>
           </a:p>
         </p:txBody>
@@ -5181,7 +5194,7 @@
               </a:defRPr>
             </a:pPr>
             <a:r>
-              <a:t>CUANDO TERMINES ESTE CURSO</a:t>
+              <a:t>AO CONCLUIR ESTE CURSO</a:t>
             </a:r>
           </a:p>
           <a:p>
@@ -5204,7 +5217,7 @@
               </a:defRPr>
             </a:pPr>
             <a:r>
-              <a:t>Tendrás un blog</a:t>
+              <a:t>Você terá um blog</a:t>
             </a:r>
           </a:p>
           <a:p>
@@ -5217,7 +5230,7 @@
               </a:defRPr>
             </a:pPr>
             <a:r>
-              <a:t>PROFESIONAL</a:t>
+              <a:t>PROFISSIONAL</a:t>
             </a:r>
           </a:p>
           <a:p>
@@ -5240,7 +5253,7 @@
               </a:defRPr>
             </a:pPr>
             <a:r>
-              <a:t>✓ Control total</a:t>
+              <a:t>✓ Controle total</a:t>
             </a:r>
           </a:p>
           <a:p>
@@ -5253,7 +5266,7 @@
               </a:defRPr>
             </a:pPr>
             <a:r>
-              <a:t>✓ Dominio gratis</a:t>
+              <a:t>✓ Endereço no GitHub Pages (github.io)</a:t>
             </a:r>
           </a:p>
           <a:p>
@@ -5266,7 +5279,7 @@
               </a:defRPr>
             </a:pPr>
             <a:r>
-              <a:t>✓ Hosting gratis</a:t>
+              <a:t>✓ Hospedagem sem custo no GitHub Pages</a:t>
             </a:r>
           </a:p>
           <a:p>
@@ -5279,7 +5292,7 @@
               </a:defRPr>
             </a:pPr>
             <a:r>
-              <a:t>✓ NADA DE PAGAR</a:t>
+              <a:t>✓ SEM MENSALIDADE DE HOSPEDAGEM</a:t>
             </a:r>
           </a:p>
           <a:p>
@@ -5302,7 +5315,7 @@
               </a:defRPr>
             </a:pPr>
             <a:r>
-              <a:t>No una página de Wix.</a:t>
+              <a:t>Com estrutura própria, sem depender de um construtor visual.</a:t>
             </a:r>
           </a:p>
           <a:p>
@@ -5314,9 +5327,6 @@
                 <a:latin typeface="Inter"/>
               </a:defRPr>
             </a:pPr>
-            <a:r>
-              <a:t>No un blog de WordPress.</a:t>
-            </a:r>
           </a:p>
           <a:p>
             <a:pPr algn="ctr">
@@ -5327,6 +5337,9 @@
                 <a:latin typeface="Inter"/>
               </a:defRPr>
             </a:pPr>
+            <a:r>
+              <a:t>Um blog de verdade.</a:t>
+            </a:r>
           </a:p>
           <a:p>
             <a:pPr algn="ctr">
@@ -5338,20 +5351,7 @@
               </a:defRPr>
             </a:pPr>
             <a:r>
-              <a:t>Un blog REAL.</a:t>
-            </a:r>
-          </a:p>
-          <a:p>
-            <a:pPr algn="ctr">
-              <a:defRPr sz="2800">
-                <a:solidFill>
-                  <a:srgbClr val="FFFFFF"/>
-                </a:solidFill>
-                <a:latin typeface="Inter"/>
-              </a:defRPr>
-            </a:pPr>
-            <a:r>
-              <a:t>Que TEMES que funcione.</a:t>
+              <a:t>Que você sabe que funciona.</a:t>
             </a:r>
           </a:p>
         </p:txBody>
@@ -5413,7 +5413,7 @@
               </a:defRPr>
             </a:pPr>
             <a:r>
-              <a:t>¿Por qué Jekyll y no WordPress?</a:t>
+              <a:t>Jekyll ou WordPress: qual escolher?</a:t>
             </a:r>
           </a:p>
         </p:txBody>
@@ -5475,7 +5475,7 @@
               </a:defRPr>
             </a:pPr>
             <a:r>
-              <a:t>$50-200 al año</a:t>
+              <a:t>Hospedagem pode ter custo</a:t>
             </a:r>
           </a:p>
           <a:p>
@@ -5485,7 +5485,7 @@
               </a:defRPr>
             </a:pPr>
             <a:r>
-              <a:t>🐢 Lento (~3s)</a:t>
+              <a:t>Amplo ecossistema de plugins</a:t>
             </a:r>
           </a:p>
           <a:p>
@@ -5495,7 +5495,7 @@
               </a:defRPr>
             </a:pPr>
             <a:r>
-              <a:t>🔓 Vulnerable</a:t>
+              <a:t>Requer atualizações frequentes</a:t>
             </a:r>
           </a:p>
           <a:p>
@@ -5505,7 +5505,7 @@
               </a:defRPr>
             </a:pPr>
             <a:r>
-              <a:t>📦 Pesado</a:t>
+              <a:t>Usa banco de dados</a:t>
             </a:r>
           </a:p>
         </p:txBody>
@@ -5567,7 +5567,7 @@
               </a:defRPr>
             </a:pPr>
             <a:r>
-              <a:t>$0 Gratis</a:t>
+              <a:t>GitHub Pages sem custo de hospedagem</a:t>
             </a:r>
           </a:p>
           <a:p>
@@ -5577,7 +5577,7 @@
               </a:defRPr>
             </a:pPr>
             <a:r>
-              <a:t>⚡ Velocidad</a:t>
+              <a:t>Arquivos estáticos e leves</a:t>
             </a:r>
           </a:p>
           <a:p>
@@ -5587,7 +5587,7 @@
               </a:defRPr>
             </a:pPr>
             <a:r>
-              <a:t>🔒 Seguro</a:t>
+              <a:t>Sem banco de dados em execução</a:t>
             </a:r>
           </a:p>
           <a:p>
@@ -5597,7 +5597,7 @@
               </a:defRPr>
             </a:pPr>
             <a:r>
-              <a:t>📝 Minimalista</a:t>
+              <a:t>Publicação pelo Git</a:t>
             </a:r>
           </a:p>
         </p:txBody>
@@ -5659,7 +5659,7 @@
               </a:defRPr>
             </a:pPr>
             <a:r>
-              <a:t>ESTO ES LO QUE LOGRAMOS CON JEKYLL</a:t>
+              <a:t>UM BLOG PUBLICADO COM JEKYLL</a:t>
             </a:r>
           </a:p>
         </p:txBody>
@@ -5713,7 +5713,7 @@
               </a:defRPr>
             </a:pPr>
             <a:r>
-              <a:t>[Screenshot de tu blog en alta resolución]</a:t>
+              <a:t>[Insira uma captura de tela do blog]</a:t>
             </a:r>
           </a:p>
         </p:txBody>
@@ -5749,7 +5749,7 @@
               </a:defRPr>
             </a:pPr>
             <a:r>
-              <a:t>⚡ 95+ Lighthouse Score  |  Tu blog en 2 horas</a:t>
+              <a:t>⚡ Site estático  |  Publicação pelo GitHub Pages</a:t>
             </a:r>
           </a:p>
         </p:txBody>

</xml_diff>